<commit_message>
Regenerate editable slide with complete data layout
Match original screenshot with side-by-side data cards containing all
metrics (total, LITE, SMB, Mid-Market, growth %). Add second slide with
editable data table. Remove cluttered charts that hid key data.

Co-authored-by: maiagordon-commits <maiagordon-commits@users.noreply.github.com>
</commit_message>
<xml_diff>
--- a/migration_progress_slide.pptx
+++ b/migration_progress_slide.pptx
@@ -6,6 +6,7 @@
   </p:sldMasterIdLst>
   <p:sldIdLst>
     <p:sldId id="256" r:id="rId7"/>
+    <p:sldId id="257" r:id="rId8"/>
   </p:sldIdLst>
   <p:sldSz cx="12191695" cy="6858000" type="screen4x3"/>
   <p:notesSz cx="6858000" cy="9144000"/>
@@ -105,304 +106,6 @@
     </a:lvl9pPr>
   </p:defaultTextStyle>
 </p:presentation>
-</file>
-
-<file path=ppt/charts/chart1.xml><?xml version="1.0" encoding="utf-8"?>
-<c:chartSpace xmlns:c="http://schemas.openxmlformats.org/drawingml/2006/chart" xmlns:a="http://schemas.openxmlformats.org/drawingml/2006/main" xmlns:r="http://schemas.openxmlformats.org/officeDocument/2006/relationships">
-  <c:date1904 val="0"/>
-  <c:chart>
-    <c:title>
-      <c:layout/>
-      <c:overlay val="0"/>
-    </c:title>
-    <c:autoTitleDeleted val="0"/>
-    <c:plotArea>
-      <c:barChart>
-        <c:barDir val="col"/>
-        <c:grouping val="stacked"/>
-        <c:ser>
-          <c:idx val="0"/>
-          <c:order val="0"/>
-          <c:tx>
-            <c:strRef>
-              <c:f>Sheet1!$B$1</c:f>
-              <c:strCache>
-                <c:ptCount val="1"/>
-                <c:pt idx="0">
-                  <c:v>LITE Segment</c:v>
-                </c:pt>
-              </c:strCache>
-            </c:strRef>
-          </c:tx>
-          <c:spPr>
-            <a:solidFill>
-              <a:srgbClr val="1B4F8A"/>
-            </a:solidFill>
-          </c:spPr>
-          <c:cat>
-            <c:strRef>
-              <c:f>Sheet1!$A$2:$A$3</c:f>
-              <c:strCache>
-                <c:ptCount val="2"/>
-                <c:pt idx="0">
-                  <c:v>June 8th</c:v>
-                </c:pt>
-                <c:pt idx="1">
-                  <c:v>June 15th</c:v>
-                </c:pt>
-              </c:strCache>
-            </c:strRef>
-          </c:cat>
-          <c:val>
-            <c:numRef>
-              <c:f>Sheet1!$B$2:$B$3</c:f>
-              <c:numCache>
-                <c:formatCode>General</c:formatCode>
-                <c:ptCount val="2"/>
-                <c:pt idx="0">
-                  <c:v>380</c:v>
-                </c:pt>
-                <c:pt idx="1">
-                  <c:v>840</c:v>
-                </c:pt>
-              </c:numCache>
-            </c:numRef>
-          </c:val>
-        </c:ser>
-        <c:ser>
-          <c:idx val="1"/>
-          <c:order val="1"/>
-          <c:tx>
-            <c:strRef>
-              <c:f>Sheet1!$C$1</c:f>
-              <c:strCache>
-                <c:ptCount val="1"/>
-                <c:pt idx="0">
-                  <c:v>SMB Segment</c:v>
-                </c:pt>
-              </c:strCache>
-            </c:strRef>
-          </c:tx>
-          <c:spPr>
-            <a:solidFill>
-              <a:srgbClr val="2E9E5B"/>
-            </a:solidFill>
-          </c:spPr>
-          <c:cat>
-            <c:strRef>
-              <c:f>Sheet1!$A$2:$A$3</c:f>
-              <c:strCache>
-                <c:ptCount val="2"/>
-                <c:pt idx="0">
-                  <c:v>June 8th</c:v>
-                </c:pt>
-                <c:pt idx="1">
-                  <c:v>June 15th</c:v>
-                </c:pt>
-              </c:strCache>
-            </c:strRef>
-          </c:cat>
-          <c:val>
-            <c:numRef>
-              <c:f>Sheet1!$C$2:$C$3</c:f>
-              <c:numCache>
-                <c:formatCode>General</c:formatCode>
-                <c:ptCount val="2"/>
-                <c:pt idx="0">
-                  <c:v>717</c:v>
-                </c:pt>
-                <c:pt idx="1">
-                  <c:v>1810</c:v>
-                </c:pt>
-              </c:numCache>
-            </c:numRef>
-          </c:val>
-        </c:ser>
-        <c:gapWidth val="80"/>
-        <c:overlap val="100"/>
-        <c:axId val="-2068027336"/>
-        <c:axId val="-2113994440"/>
-      </c:barChart>
-      <c:catAx>
-        <c:axId val="-2068027336"/>
-        <c:scaling>
-          <c:orientation val="minMax"/>
-        </c:scaling>
-        <c:delete val="0"/>
-        <c:axPos val="b"/>
-        <c:majorTickMark val="out"/>
-        <c:minorTickMark val="none"/>
-        <c:tickLblPos val="nextTo"/>
-        <c:crossAx val="-2113994440"/>
-        <c:crosses val="autoZero"/>
-        <c:auto val="1"/>
-        <c:lblAlgn val="ctr"/>
-        <c:lblOffset val="100"/>
-        <c:noMultiLvlLbl val="0"/>
-      </c:catAx>
-      <c:valAx>
-        <c:axId val="-2113994440"/>
-        <c:scaling>
-          <c:max val="3000.0"/>
-        </c:scaling>
-        <c:delete val="0"/>
-        <c:axPos val="l"/>
-        <c:majorGridlines/>
-        <c:majorTickMark val="out"/>
-        <c:minorTickMark val="none"/>
-        <c:tickLblPos val="nextTo"/>
-        <c:crossAx val="-2068027336"/>
-        <c:crosses val="autoZero"/>
-      </c:valAx>
-    </c:plotArea>
-    <c:legend>
-      <c:legendPos val="t"/>
-      <c:overlay val="0"/>
-    </c:legend>
-    <c:dispBlanksAs val="gap"/>
-  </c:chart>
-  <c:txPr>
-    <a:bodyPr/>
-    <a:lstStyle/>
-    <a:p>
-      <a:pPr>
-        <a:defRPr sz="1800"/>
-      </a:pPr>
-      <a:endParaRPr lang="en-US"/>
-    </a:p>
-  </c:txPr>
-  <c:externalData r:id="rId1">
-    <c:autoUpdate val="0"/>
-  </c:externalData>
-</c:chartSpace>
-</file>
-
-<file path=ppt/charts/chart2.xml><?xml version="1.0" encoding="utf-8"?>
-<c:chartSpace xmlns:c="http://schemas.openxmlformats.org/drawingml/2006/chart" xmlns:a="http://schemas.openxmlformats.org/drawingml/2006/main" xmlns:r="http://schemas.openxmlformats.org/officeDocument/2006/relationships">
-  <c:date1904 val="0"/>
-  <c:chart>
-    <c:title>
-      <c:layout/>
-      <c:overlay val="0"/>
-    </c:title>
-    <c:autoTitleDeleted val="0"/>
-    <c:plotArea>
-      <c:lineChart>
-        <c:grouping val="standard"/>
-        <c:varyColors val="0"/>
-        <c:ser>
-          <c:idx val="0"/>
-          <c:order val="0"/>
-          <c:tx>
-            <c:strRef>
-              <c:f>Sheet1!$B$1</c:f>
-              <c:strCache>
-                <c:ptCount val="1"/>
-                <c:pt idx="0">
-                  <c:v>Total Accounts</c:v>
-                </c:pt>
-              </c:strCache>
-            </c:strRef>
-          </c:tx>
-          <c:spPr>
-            <a:ln w="31750">
-              <a:solidFill>
-                <a:srgbClr val="2E9E5B"/>
-              </a:solidFill>
-            </a:ln>
-          </c:spPr>
-          <c:marker>
-            <c:size val="8"/>
-            <c:spPr>
-              <a:solidFill>
-                <a:srgbClr val="2E9E5B"/>
-              </a:solidFill>
-            </c:spPr>
-          </c:marker>
-          <c:cat>
-            <c:strRef>
-              <c:f>Sheet1!$A$2:$A$3</c:f>
-              <c:strCache>
-                <c:ptCount val="2"/>
-                <c:pt idx="0">
-                  <c:v>June 8th</c:v>
-                </c:pt>
-                <c:pt idx="1">
-                  <c:v>June 15th</c:v>
-                </c:pt>
-              </c:strCache>
-            </c:strRef>
-          </c:cat>
-          <c:val>
-            <c:numRef>
-              <c:f>Sheet1!$B$2:$B$3</c:f>
-              <c:numCache>
-                <c:formatCode>General</c:formatCode>
-                <c:ptCount val="2"/>
-                <c:pt idx="0">
-                  <c:v>1097</c:v>
-                </c:pt>
-                <c:pt idx="1">
-                  <c:v>2650</c:v>
-                </c:pt>
-              </c:numCache>
-            </c:numRef>
-          </c:val>
-          <c:smooth val="0"/>
-        </c:ser>
-        <c:marker val="1"/>
-        <c:smooth val="0"/>
-        <c:axId val="2118791784"/>
-        <c:axId val="2140495176"/>
-      </c:lineChart>
-      <c:catAx>
-        <c:axId val="2118791784"/>
-        <c:scaling>
-          <c:orientation val="minMax"/>
-        </c:scaling>
-        <c:delete val="0"/>
-        <c:axPos val="b"/>
-        <c:majorTickMark val="out"/>
-        <c:minorTickMark val="none"/>
-        <c:tickLblPos val="nextTo"/>
-        <c:crossAx val="2140495176"/>
-        <c:crosses val="autoZero"/>
-        <c:auto val="1"/>
-        <c:lblAlgn val="ctr"/>
-        <c:lblOffset val="100"/>
-        <c:noMultiLvlLbl val="0"/>
-      </c:catAx>
-      <c:valAx>
-        <c:axId val="2140495176"/>
-        <c:scaling/>
-        <c:delete val="0"/>
-        <c:axPos val="l"/>
-        <c:majorGridlines/>
-        <c:majorTickMark val="out"/>
-        <c:minorTickMark val="none"/>
-        <c:tickLblPos val="nextTo"/>
-        <c:crossAx val="2118791784"/>
-        <c:crosses val="autoZero"/>
-      </c:valAx>
-    </c:plotArea>
-    <c:plotVisOnly val="1"/>
-    <c:dispBlanksAs val="gap"/>
-    <c:showDLblsOverMax val="0"/>
-  </c:chart>
-  <c:txPr>
-    <a:bodyPr/>
-    <a:lstStyle/>
-    <a:p>
-      <a:pPr>
-        <a:defRPr sz="1800"/>
-      </a:pPr>
-      <a:endParaRPr lang="en-US"/>
-    </a:p>
-  </c:txPr>
-  <c:externalData r:id="rId1">
-    <c:autoUpdate val="0"/>
-  </c:externalData>
-</c:chartSpace>
 </file>
 
 <file path=ppt/slideLayouts/slideLayout1.xml><?xml version="1.0" encoding="utf-8"?>
@@ -3437,8 +3140,8 @@
         </p:nvSpPr>
         <p:spPr>
           <a:xfrm>
-            <a:off x="731520" y="411480"/>
-            <a:ext cx="10058400" cy="640080"/>
+            <a:off x="731520" y="502920"/>
+            <a:ext cx="10515600" cy="685800"/>
           </a:xfrm>
           <a:prstGeom prst="rect">
             <a:avLst/>
@@ -3451,8 +3154,8 @@
           </a:bodyPr>
           <a:lstStyle/>
           <a:p>
-            <a:pPr algn="l">
-              <a:defRPr sz="2800" b="1" i="0">
+            <a:pPr algn="ctr">
+              <a:defRPr sz="3000" b="1" i="0">
                 <a:solidFill>
                   <a:srgbClr val="1E293B"/>
                 </a:solidFill>
@@ -3472,8 +3175,8 @@
         </p:nvSpPr>
         <p:spPr>
           <a:xfrm>
-            <a:off x="1097280" y="1417320"/>
-            <a:ext cx="3787444" cy="201168"/>
+            <a:off x="1371600" y="1600200"/>
+            <a:ext cx="3296412" cy="256032"/>
           </a:xfrm>
           <a:prstGeom prst="roundRect">
             <a:avLst>
@@ -3517,8 +3220,8 @@
         </p:nvSpPr>
         <p:spPr>
           <a:xfrm>
-            <a:off x="4884724" y="1417320"/>
-            <a:ext cx="2192731" cy="201168"/>
+            <a:off x="4668012" y="1600200"/>
+            <a:ext cx="2354580" cy="256032"/>
           </a:xfrm>
           <a:prstGeom prst="roundRect">
             <a:avLst>
@@ -3562,8 +3265,8 @@
         </p:nvSpPr>
         <p:spPr>
           <a:xfrm>
-            <a:off x="7077455" y="1417320"/>
-            <a:ext cx="3986785" cy="201168"/>
+            <a:off x="7022592" y="1600200"/>
+            <a:ext cx="3767328" cy="256032"/>
           </a:xfrm>
           <a:prstGeom prst="roundRect">
             <a:avLst>
@@ -3607,8 +3310,8 @@
         </p:nvSpPr>
         <p:spPr>
           <a:xfrm>
-            <a:off x="1595628" y="1408176"/>
-            <a:ext cx="219456" cy="219456"/>
+            <a:off x="1748332" y="1600200"/>
+            <a:ext cx="256032" cy="256032"/>
           </a:xfrm>
           <a:prstGeom prst="ellipse">
             <a:avLst/>
@@ -3650,8 +3353,8 @@
         </p:nvSpPr>
         <p:spPr>
           <a:xfrm>
-            <a:off x="1138428" y="1737360"/>
-            <a:ext cx="1097280" cy="274320"/>
+            <a:off x="1245412" y="1984248"/>
+            <a:ext cx="1188720" cy="320040"/>
           </a:xfrm>
           <a:prstGeom prst="rect">
             <a:avLst/>
@@ -3665,7 +3368,7 @@
           <a:lstStyle/>
           <a:p>
             <a:pPr algn="ctr">
-              <a:defRPr sz="1000" b="0" i="0">
+              <a:defRPr sz="1100" b="0" i="0">
                 <a:solidFill>
                   <a:srgbClr val="1E293B"/>
                 </a:solidFill>
@@ -3685,8 +3388,8 @@
         </p:nvSpPr>
         <p:spPr>
           <a:xfrm>
-            <a:off x="7077456" y="1408176"/>
-            <a:ext cx="219456" cy="219456"/>
+            <a:off x="6834225" y="1600200"/>
+            <a:ext cx="256032" cy="256032"/>
           </a:xfrm>
           <a:prstGeom prst="ellipse">
             <a:avLst/>
@@ -3728,8 +3431,8 @@
         </p:nvSpPr>
         <p:spPr>
           <a:xfrm>
-            <a:off x="6620256" y="1737360"/>
-            <a:ext cx="1097280" cy="274320"/>
+            <a:off x="6331305" y="1984248"/>
+            <a:ext cx="1188720" cy="320040"/>
           </a:xfrm>
           <a:prstGeom prst="rect">
             <a:avLst/>
@@ -3743,7 +3446,7 @@
           <a:lstStyle/>
           <a:p>
             <a:pPr algn="ctr">
-              <a:defRPr sz="1000" b="0" i="0">
+              <a:defRPr sz="1100" b="0" i="0">
                 <a:solidFill>
                   <a:srgbClr val="1E293B"/>
                 </a:solidFill>
@@ -3755,65 +3458,25 @@
           </a:p>
         </p:txBody>
       </p:sp>
-      <p:graphicFrame>
-        <p:nvGraphicFramePr>
-          <p:cNvPr id="11" name="Chart 10"/>
-          <p:cNvGraphicFramePr>
-            <a:graphicFrameLocks noGrp="1"/>
-          </p:cNvGraphicFramePr>
-          <p:nvPr/>
-        </p:nvGraphicFramePr>
-        <p:xfrm>
-          <a:off x="731520" y="2011680"/>
-          <a:ext cx="5669280" cy="3474720"/>
-        </p:xfrm>
-        <a:graphic>
-          <a:graphicData uri="http://schemas.openxmlformats.org/drawingml/2006/chart">
-            <c:chart xmlns:c="http://schemas.openxmlformats.org/drawingml/2006/chart" r:id="rId2"/>
-          </a:graphicData>
-        </a:graphic>
-      </p:graphicFrame>
-      <p:graphicFrame>
-        <p:nvGraphicFramePr>
-          <p:cNvPr id="12" name="Chart 11"/>
-          <p:cNvGraphicFramePr>
-            <a:graphicFrameLocks noGrp="1"/>
-          </p:cNvGraphicFramePr>
-          <p:nvPr/>
-        </p:nvGraphicFramePr>
-        <p:xfrm>
-          <a:off x="731520" y="5486400"/>
-          <a:ext cx="5669280" cy="1097280"/>
-        </p:xfrm>
-        <a:graphic>
-          <a:graphicData uri="http://schemas.openxmlformats.org/drawingml/2006/chart">
-            <c:chart xmlns:c="http://schemas.openxmlformats.org/drawingml/2006/chart" r:id="rId3"/>
-          </a:graphicData>
-        </a:graphic>
-      </p:graphicFrame>
-      <p:sp>
-        <p:nvSpPr>
-          <p:cNvPr id="13" name="Rounded Rectangle 12"/>
+      <p:sp>
+        <p:nvSpPr>
+          <p:cNvPr id="11" name="Oval 10"/>
           <p:cNvSpPr/>
           <p:nvPr/>
         </p:nvSpPr>
         <p:spPr>
           <a:xfrm>
-            <a:off x="7589520" y="2011680"/>
-            <a:ext cx="4114800" cy="2148840"/>
-          </a:xfrm>
-          <a:prstGeom prst="roundRect">
-            <a:avLst>
-              <a:gd name="adj" fmla="val 8000"/>
-            </a:avLst>
+            <a:off x="10036454" y="1600200"/>
+            <a:ext cx="256032" cy="256032"/>
+          </a:xfrm>
+          <a:prstGeom prst="ellipse">
+            <a:avLst/>
           </a:prstGeom>
           <a:solidFill>
-            <a:srgbClr val="FFFFFF"/>
+            <a:srgbClr val="2E9E5B"/>
           </a:solidFill>
-          <a:ln w="12700">
-            <a:solidFill>
-              <a:srgbClr val="E5E7EB"/>
-            </a:solidFill>
+          <a:ln>
+            <a:noFill/>
           </a:ln>
         </p:spPr>
         <p:style>
@@ -3840,200 +3503,27 @@
       </p:sp>
       <p:sp>
         <p:nvSpPr>
-          <p:cNvPr id="14" name="TextBox 13"/>
-          <p:cNvSpPr txBox="1"/>
-          <p:nvPr/>
-        </p:nvSpPr>
-        <p:spPr>
-          <a:xfrm>
-            <a:off x="7772400" y="2194560"/>
-            <a:ext cx="3749040" cy="320040"/>
-          </a:xfrm>
-          <a:prstGeom prst="rect">
-            <a:avLst/>
-          </a:prstGeom>
-          <a:noFill/>
-        </p:spPr>
-        <p:txBody>
-          <a:bodyPr wrap="square">
-            <a:spAutoFit/>
-          </a:bodyPr>
-          <a:lstStyle/>
-          <a:p>
-            <a:pPr algn="l">
-              <a:defRPr sz="1600" b="1" i="0">
-                <a:solidFill>
-                  <a:srgbClr val="1E293B"/>
-                </a:solidFill>
-              </a:defRPr>
-            </a:pPr>
-            <a:r>
-              <a:t>June 8th</a:t>
-            </a:r>
-          </a:p>
-        </p:txBody>
-      </p:sp>
-      <p:sp>
-        <p:nvSpPr>
-          <p:cNvPr id="15" name="TextBox 14"/>
-          <p:cNvSpPr txBox="1"/>
-          <p:nvPr/>
-        </p:nvSpPr>
-        <p:spPr>
-          <a:xfrm>
-            <a:off x="7772400" y="2560320"/>
-            <a:ext cx="3749040" cy="274320"/>
-          </a:xfrm>
-          <a:prstGeom prst="rect">
-            <a:avLst/>
-          </a:prstGeom>
-          <a:noFill/>
-        </p:spPr>
-        <p:txBody>
-          <a:bodyPr wrap="square">
-            <a:spAutoFit/>
-          </a:bodyPr>
-          <a:lstStyle/>
-          <a:p>
-            <a:pPr algn="l">
-              <a:defRPr sz="1300" b="0" i="0">
-                <a:solidFill>
-                  <a:srgbClr val="1E293B"/>
-                </a:solidFill>
-              </a:defRPr>
-            </a:pPr>
-            <a:r>
-              <a:t>Total Accounts: 1,097</a:t>
-            </a:r>
-          </a:p>
-        </p:txBody>
-      </p:sp>
-      <p:sp>
-        <p:nvSpPr>
-          <p:cNvPr id="16" name="TextBox 15"/>
-          <p:cNvSpPr txBox="1"/>
-          <p:nvPr/>
-        </p:nvSpPr>
-        <p:spPr>
-          <a:xfrm>
-            <a:off x="7772400" y="2880360"/>
-            <a:ext cx="3749040" cy="256032"/>
-          </a:xfrm>
-          <a:prstGeom prst="rect">
-            <a:avLst/>
-          </a:prstGeom>
-          <a:noFill/>
-        </p:spPr>
-        <p:txBody>
-          <a:bodyPr wrap="square">
-            <a:spAutoFit/>
-          </a:bodyPr>
-          <a:lstStyle/>
-          <a:p>
-            <a:pPr algn="l">
-              <a:defRPr sz="1100" b="0" i="0">
-                <a:solidFill>
-                  <a:srgbClr val="1B4F8A"/>
-                </a:solidFill>
-              </a:defRPr>
-            </a:pPr>
-            <a:r>
-              <a:t>LITE Segment: 380 (34.6%)</a:t>
-            </a:r>
-          </a:p>
-        </p:txBody>
-      </p:sp>
-      <p:sp>
-        <p:nvSpPr>
-          <p:cNvPr id="17" name="TextBox 16"/>
-          <p:cNvSpPr txBox="1"/>
-          <p:nvPr/>
-        </p:nvSpPr>
-        <p:spPr>
-          <a:xfrm>
-            <a:off x="7772400" y="3154680"/>
-            <a:ext cx="3749040" cy="256032"/>
-          </a:xfrm>
-          <a:prstGeom prst="rect">
-            <a:avLst/>
-          </a:prstGeom>
-          <a:noFill/>
-        </p:spPr>
-        <p:txBody>
-          <a:bodyPr wrap="square">
-            <a:spAutoFit/>
-          </a:bodyPr>
-          <a:lstStyle/>
-          <a:p>
-            <a:pPr algn="l">
-              <a:defRPr sz="1100" b="0" i="0">
-                <a:solidFill>
-                  <a:srgbClr val="2E9E5B"/>
-                </a:solidFill>
-              </a:defRPr>
-            </a:pPr>
-            <a:r>
-              <a:t>SMB Segment: 717 (65.4%)</a:t>
-            </a:r>
-          </a:p>
-        </p:txBody>
-      </p:sp>
-      <p:sp>
-        <p:nvSpPr>
-          <p:cNvPr id="18" name="TextBox 17"/>
-          <p:cNvSpPr txBox="1"/>
-          <p:nvPr/>
-        </p:nvSpPr>
-        <p:spPr>
-          <a:xfrm>
-            <a:off x="7772400" y="3429000"/>
-            <a:ext cx="3749040" cy="256032"/>
-          </a:xfrm>
-          <a:prstGeom prst="rect">
-            <a:avLst/>
-          </a:prstGeom>
-          <a:noFill/>
-        </p:spPr>
-        <p:txBody>
-          <a:bodyPr wrap="square">
-            <a:spAutoFit/>
-          </a:bodyPr>
-          <a:lstStyle/>
-          <a:p>
-            <a:pPr algn="l">
-              <a:defRPr sz="1100" b="0" i="1">
-                <a:solidFill>
-                  <a:srgbClr val="9CA3AF"/>
-                </a:solidFill>
-              </a:defRPr>
-            </a:pPr>
-            <a:r>
-              <a:t>Mid-Market: 0 (0.0%)</a:t>
-            </a:r>
-          </a:p>
-        </p:txBody>
-      </p:sp>
-      <p:sp>
-        <p:nvSpPr>
-          <p:cNvPr id="19" name="Rounded Rectangle 18"/>
+          <p:cNvPr id="12" name="Rounded Rectangle 11"/>
           <p:cNvSpPr/>
           <p:nvPr/>
         </p:nvSpPr>
         <p:spPr>
           <a:xfrm>
-            <a:off x="7772400" y="3840480"/>
-            <a:ext cx="1298664" cy="164592"/>
+            <a:off x="1066647" y="2423160"/>
+            <a:ext cx="4754880" cy="3291840"/>
           </a:xfrm>
           <a:prstGeom prst="roundRect">
             <a:avLst>
-              <a:gd name="adj" fmla="val 15000"/>
+              <a:gd name="adj" fmla="val 8000"/>
             </a:avLst>
           </a:prstGeom>
           <a:solidFill>
-            <a:srgbClr val="1B4F8A"/>
+            <a:srgbClr val="FFFFFF"/>
           </a:solidFill>
-          <a:ln>
-            <a:noFill/>
+          <a:ln w="15875">
+            <a:solidFill>
+              <a:srgbClr val="D1D5DB"/>
+            </a:solidFill>
           </a:ln>
         </p:spPr>
         <p:style>
@@ -4060,22 +3550,197 @@
       </p:sp>
       <p:sp>
         <p:nvSpPr>
-          <p:cNvPr id="20" name="Rounded Rectangle 19"/>
+          <p:cNvPr id="13" name="TextBox 12"/>
+          <p:cNvSpPr txBox="1"/>
+          <p:nvPr/>
+        </p:nvSpPr>
+        <p:spPr>
+          <a:xfrm>
+            <a:off x="1386687" y="2697480"/>
+            <a:ext cx="4114800" cy="411480"/>
+          </a:xfrm>
+          <a:prstGeom prst="rect">
+            <a:avLst/>
+          </a:prstGeom>
+          <a:noFill/>
+        </p:spPr>
+        <p:txBody>
+          <a:bodyPr wrap="square">
+            <a:spAutoFit/>
+          </a:bodyPr>
+          <a:lstStyle/>
+          <a:p>
+            <a:pPr algn="l">
+              <a:defRPr sz="2000" b="1" i="0">
+                <a:solidFill>
+                  <a:srgbClr val="1E293B"/>
+                </a:solidFill>
+              </a:defRPr>
+            </a:pPr>
+            <a:r>
+              <a:t>June 8th</a:t>
+            </a:r>
+          </a:p>
+        </p:txBody>
+      </p:sp>
+      <p:sp>
+        <p:nvSpPr>
+          <p:cNvPr id="14" name="TextBox 13"/>
+          <p:cNvSpPr txBox="1"/>
+          <p:nvPr/>
+        </p:nvSpPr>
+        <p:spPr>
+          <a:xfrm>
+            <a:off x="1386687" y="3200400"/>
+            <a:ext cx="4114800" cy="320040"/>
+          </a:xfrm>
+          <a:prstGeom prst="rect">
+            <a:avLst/>
+          </a:prstGeom>
+          <a:noFill/>
+        </p:spPr>
+        <p:txBody>
+          <a:bodyPr wrap="square">
+            <a:spAutoFit/>
+          </a:bodyPr>
+          <a:lstStyle/>
+          <a:p>
+            <a:pPr algn="l">
+              <a:defRPr sz="1600" b="1" i="0">
+                <a:solidFill>
+                  <a:srgbClr val="1E293B"/>
+                </a:solidFill>
+              </a:defRPr>
+            </a:pPr>
+            <a:r>
+              <a:t>Total Accounts: 1,097</a:t>
+            </a:r>
+          </a:p>
+        </p:txBody>
+      </p:sp>
+      <p:sp>
+        <p:nvSpPr>
+          <p:cNvPr id="15" name="TextBox 14"/>
+          <p:cNvSpPr txBox="1"/>
+          <p:nvPr/>
+        </p:nvSpPr>
+        <p:spPr>
+          <a:xfrm>
+            <a:off x="1386687" y="3703320"/>
+            <a:ext cx="4114800" cy="292608"/>
+          </a:xfrm>
+          <a:prstGeom prst="rect">
+            <a:avLst/>
+          </a:prstGeom>
+          <a:noFill/>
+        </p:spPr>
+        <p:txBody>
+          <a:bodyPr wrap="square">
+            <a:spAutoFit/>
+          </a:bodyPr>
+          <a:lstStyle/>
+          <a:p>
+            <a:pPr algn="l">
+              <a:defRPr sz="1400" b="1" i="0">
+                <a:solidFill>
+                  <a:srgbClr val="1B4F8A"/>
+                </a:solidFill>
+              </a:defRPr>
+            </a:pPr>
+            <a:r>
+              <a:t>LITE Segment: 380 (34.6%)</a:t>
+            </a:r>
+          </a:p>
+        </p:txBody>
+      </p:sp>
+      <p:sp>
+        <p:nvSpPr>
+          <p:cNvPr id="16" name="TextBox 15"/>
+          <p:cNvSpPr txBox="1"/>
+          <p:nvPr/>
+        </p:nvSpPr>
+        <p:spPr>
+          <a:xfrm>
+            <a:off x="1386687" y="4087368"/>
+            <a:ext cx="4114800" cy="292608"/>
+          </a:xfrm>
+          <a:prstGeom prst="rect">
+            <a:avLst/>
+          </a:prstGeom>
+          <a:noFill/>
+        </p:spPr>
+        <p:txBody>
+          <a:bodyPr wrap="square">
+            <a:spAutoFit/>
+          </a:bodyPr>
+          <a:lstStyle/>
+          <a:p>
+            <a:pPr algn="l">
+              <a:defRPr sz="1400" b="1" i="0">
+                <a:solidFill>
+                  <a:srgbClr val="2E9E5B"/>
+                </a:solidFill>
+              </a:defRPr>
+            </a:pPr>
+            <a:r>
+              <a:t>SMB Segment: 717 (65.4%)</a:t>
+            </a:r>
+          </a:p>
+        </p:txBody>
+      </p:sp>
+      <p:sp>
+        <p:nvSpPr>
+          <p:cNvPr id="17" name="TextBox 16"/>
+          <p:cNvSpPr txBox="1"/>
+          <p:nvPr/>
+        </p:nvSpPr>
+        <p:spPr>
+          <a:xfrm>
+            <a:off x="1386687" y="4471416"/>
+            <a:ext cx="4114800" cy="292608"/>
+          </a:xfrm>
+          <a:prstGeom prst="rect">
+            <a:avLst/>
+          </a:prstGeom>
+          <a:noFill/>
+        </p:spPr>
+        <p:txBody>
+          <a:bodyPr wrap="square">
+            <a:spAutoFit/>
+          </a:bodyPr>
+          <a:lstStyle/>
+          <a:p>
+            <a:pPr algn="l">
+              <a:defRPr sz="1400" b="0" i="1">
+                <a:solidFill>
+                  <a:srgbClr val="9CA3AF"/>
+                </a:solidFill>
+              </a:defRPr>
+            </a:pPr>
+            <a:r>
+              <a:t>Mid-Market: 0 (0.0%)</a:t>
+            </a:r>
+          </a:p>
+        </p:txBody>
+      </p:sp>
+      <p:sp>
+        <p:nvSpPr>
+          <p:cNvPr id="18" name="Rounded Rectangle 17"/>
           <p:cNvSpPr/>
           <p:nvPr/>
         </p:nvSpPr>
         <p:spPr>
           <a:xfrm>
-            <a:off x="9071064" y="3840480"/>
-            <a:ext cx="2450376" cy="164592"/>
+            <a:off x="1386687" y="4974336"/>
+            <a:ext cx="1425363" cy="201168"/>
           </a:xfrm>
           <a:prstGeom prst="roundRect">
             <a:avLst>
-              <a:gd name="adj" fmla="val 15000"/>
+              <a:gd name="adj" fmla="val 20000"/>
             </a:avLst>
           </a:prstGeom>
           <a:solidFill>
-            <a:srgbClr val="2E9E5B"/>
+            <a:srgbClr val="1B4F8A"/>
           </a:solidFill>
           <a:ln>
             <a:noFill/>
@@ -4105,27 +3770,25 @@
       </p:sp>
       <p:sp>
         <p:nvSpPr>
-          <p:cNvPr id="21" name="Rounded Rectangle 20"/>
+          <p:cNvPr id="19" name="Rounded Rectangle 18"/>
           <p:cNvSpPr/>
           <p:nvPr/>
         </p:nvSpPr>
         <p:spPr>
           <a:xfrm>
-            <a:off x="7589520" y="4434840"/>
-            <a:ext cx="4114800" cy="2148840"/>
+            <a:off x="2812050" y="4974336"/>
+            <a:ext cx="2689437" cy="201168"/>
           </a:xfrm>
           <a:prstGeom prst="roundRect">
             <a:avLst>
-              <a:gd name="adj" fmla="val 8000"/>
+              <a:gd name="adj" fmla="val 20000"/>
             </a:avLst>
           </a:prstGeom>
           <a:solidFill>
-            <a:srgbClr val="FFFFFF"/>
+            <a:srgbClr val="2E9E5B"/>
           </a:solidFill>
-          <a:ln w="12700">
-            <a:solidFill>
-              <a:srgbClr val="E5E7EB"/>
-            </a:solidFill>
+          <a:ln>
+            <a:noFill/>
           </a:ln>
         </p:spPr>
         <p:style>
@@ -4152,235 +3815,27 @@
       </p:sp>
       <p:sp>
         <p:nvSpPr>
-          <p:cNvPr id="22" name="TextBox 21"/>
-          <p:cNvSpPr txBox="1"/>
-          <p:nvPr/>
-        </p:nvSpPr>
-        <p:spPr>
-          <a:xfrm>
-            <a:off x="7772400" y="4617720"/>
-            <a:ext cx="3749040" cy="320040"/>
-          </a:xfrm>
-          <a:prstGeom prst="rect">
-            <a:avLst/>
-          </a:prstGeom>
-          <a:noFill/>
-        </p:spPr>
-        <p:txBody>
-          <a:bodyPr wrap="square">
-            <a:spAutoFit/>
-          </a:bodyPr>
-          <a:lstStyle/>
-          <a:p>
-            <a:pPr algn="l">
-              <a:defRPr sz="1600" b="1" i="0">
-                <a:solidFill>
-                  <a:srgbClr val="1E293B"/>
-                </a:solidFill>
-              </a:defRPr>
-            </a:pPr>
-            <a:r>
-              <a:t>June 15th</a:t>
-            </a:r>
-          </a:p>
-        </p:txBody>
-      </p:sp>
-      <p:sp>
-        <p:nvSpPr>
-          <p:cNvPr id="23" name="TextBox 22"/>
-          <p:cNvSpPr txBox="1"/>
-          <p:nvPr/>
-        </p:nvSpPr>
-        <p:spPr>
-          <a:xfrm>
-            <a:off x="7772400" y="4983480"/>
-            <a:ext cx="3749040" cy="274320"/>
-          </a:xfrm>
-          <a:prstGeom prst="rect">
-            <a:avLst/>
-          </a:prstGeom>
-          <a:noFill/>
-        </p:spPr>
-        <p:txBody>
-          <a:bodyPr wrap="square">
-            <a:spAutoFit/>
-          </a:bodyPr>
-          <a:lstStyle/>
-          <a:p>
-            <a:pPr algn="l">
-              <a:defRPr sz="1300" b="1" i="0">
-                <a:solidFill>
-                  <a:srgbClr val="2E9E5B"/>
-                </a:solidFill>
-              </a:defRPr>
-            </a:pPr>
-            <a:r>
-              <a:t>↑ +141.6%</a:t>
-            </a:r>
-          </a:p>
-        </p:txBody>
-      </p:sp>
-      <p:sp>
-        <p:nvSpPr>
-          <p:cNvPr id="24" name="TextBox 23"/>
-          <p:cNvSpPr txBox="1"/>
-          <p:nvPr/>
-        </p:nvSpPr>
-        <p:spPr>
-          <a:xfrm>
-            <a:off x="7772400" y="5303520"/>
-            <a:ext cx="3749040" cy="274320"/>
-          </a:xfrm>
-          <a:prstGeom prst="rect">
-            <a:avLst/>
-          </a:prstGeom>
-          <a:noFill/>
-        </p:spPr>
-        <p:txBody>
-          <a:bodyPr wrap="square">
-            <a:spAutoFit/>
-          </a:bodyPr>
-          <a:lstStyle/>
-          <a:p>
-            <a:pPr algn="l">
-              <a:defRPr sz="1300" b="0" i="0">
-                <a:solidFill>
-                  <a:srgbClr val="1E293B"/>
-                </a:solidFill>
-              </a:defRPr>
-            </a:pPr>
-            <a:r>
-              <a:t>Total Accounts: 2,650</a:t>
-            </a:r>
-          </a:p>
-        </p:txBody>
-      </p:sp>
-      <p:sp>
-        <p:nvSpPr>
-          <p:cNvPr id="25" name="TextBox 24"/>
-          <p:cNvSpPr txBox="1"/>
-          <p:nvPr/>
-        </p:nvSpPr>
-        <p:spPr>
-          <a:xfrm>
-            <a:off x="7772400" y="5623560"/>
-            <a:ext cx="3749040" cy="256032"/>
-          </a:xfrm>
-          <a:prstGeom prst="rect">
-            <a:avLst/>
-          </a:prstGeom>
-          <a:noFill/>
-        </p:spPr>
-        <p:txBody>
-          <a:bodyPr wrap="square">
-            <a:spAutoFit/>
-          </a:bodyPr>
-          <a:lstStyle/>
-          <a:p>
-            <a:pPr algn="l">
-              <a:defRPr sz="1100" b="0" i="0">
-                <a:solidFill>
-                  <a:srgbClr val="1B4F8A"/>
-                </a:solidFill>
-              </a:defRPr>
-            </a:pPr>
-            <a:r>
-              <a:t>LITE Segment: 840 (31.7%)</a:t>
-            </a:r>
-          </a:p>
-        </p:txBody>
-      </p:sp>
-      <p:sp>
-        <p:nvSpPr>
-          <p:cNvPr id="26" name="TextBox 25"/>
-          <p:cNvSpPr txBox="1"/>
-          <p:nvPr/>
-        </p:nvSpPr>
-        <p:spPr>
-          <a:xfrm>
-            <a:off x="7772400" y="5897880"/>
-            <a:ext cx="3749040" cy="256032"/>
-          </a:xfrm>
-          <a:prstGeom prst="rect">
-            <a:avLst/>
-          </a:prstGeom>
-          <a:noFill/>
-        </p:spPr>
-        <p:txBody>
-          <a:bodyPr wrap="square">
-            <a:spAutoFit/>
-          </a:bodyPr>
-          <a:lstStyle/>
-          <a:p>
-            <a:pPr algn="l">
-              <a:defRPr sz="1100" b="0" i="0">
-                <a:solidFill>
-                  <a:srgbClr val="2E9E5B"/>
-                </a:solidFill>
-              </a:defRPr>
-            </a:pPr>
-            <a:r>
-              <a:t>SMB Segment: 1,810 (68.3%)</a:t>
-            </a:r>
-          </a:p>
-        </p:txBody>
-      </p:sp>
-      <p:sp>
-        <p:nvSpPr>
-          <p:cNvPr id="27" name="TextBox 26"/>
-          <p:cNvSpPr txBox="1"/>
-          <p:nvPr/>
-        </p:nvSpPr>
-        <p:spPr>
-          <a:xfrm>
-            <a:off x="7772400" y="6172200"/>
-            <a:ext cx="3749040" cy="256032"/>
-          </a:xfrm>
-          <a:prstGeom prst="rect">
-            <a:avLst/>
-          </a:prstGeom>
-          <a:noFill/>
-        </p:spPr>
-        <p:txBody>
-          <a:bodyPr wrap="square">
-            <a:spAutoFit/>
-          </a:bodyPr>
-          <a:lstStyle/>
-          <a:p>
-            <a:pPr algn="l">
-              <a:defRPr sz="1100" b="0" i="1">
-                <a:solidFill>
-                  <a:srgbClr val="9CA3AF"/>
-                </a:solidFill>
-              </a:defRPr>
-            </a:pPr>
-            <a:r>
-              <a:t>Mid-Market: Pending</a:t>
-            </a:r>
-          </a:p>
-        </p:txBody>
-      </p:sp>
-      <p:sp>
-        <p:nvSpPr>
-          <p:cNvPr id="28" name="Rounded Rectangle 27"/>
+          <p:cNvPr id="20" name="Rounded Rectangle 19"/>
           <p:cNvSpPr/>
           <p:nvPr/>
         </p:nvSpPr>
         <p:spPr>
           <a:xfrm>
-            <a:off x="7772400" y="6583680"/>
-            <a:ext cx="1188374" cy="164592"/>
+            <a:off x="6370167" y="2423160"/>
+            <a:ext cx="4754880" cy="3291840"/>
           </a:xfrm>
           <a:prstGeom prst="roundRect">
             <a:avLst>
-              <a:gd name="adj" fmla="val 15000"/>
+              <a:gd name="adj" fmla="val 8000"/>
             </a:avLst>
           </a:prstGeom>
           <a:solidFill>
-            <a:srgbClr val="1B4F8A"/>
+            <a:srgbClr val="FFFFFF"/>
           </a:solidFill>
-          <a:ln>
-            <a:noFill/>
+          <a:ln w="15875">
+            <a:solidFill>
+              <a:srgbClr val="D1D5DB"/>
+            </a:solidFill>
           </a:ln>
         </p:spPr>
         <p:style>
@@ -4407,18 +3862,53 @@
       </p:sp>
       <p:sp>
         <p:nvSpPr>
-          <p:cNvPr id="29" name="Rounded Rectangle 28"/>
+          <p:cNvPr id="21" name="TextBox 20"/>
+          <p:cNvSpPr txBox="1"/>
+          <p:nvPr/>
+        </p:nvSpPr>
+        <p:spPr>
+          <a:xfrm>
+            <a:off x="6690207" y="2697480"/>
+            <a:ext cx="4114800" cy="411480"/>
+          </a:xfrm>
+          <a:prstGeom prst="rect">
+            <a:avLst/>
+          </a:prstGeom>
+          <a:noFill/>
+        </p:spPr>
+        <p:txBody>
+          <a:bodyPr wrap="square">
+            <a:spAutoFit/>
+          </a:bodyPr>
+          <a:lstStyle/>
+          <a:p>
+            <a:pPr algn="l">
+              <a:defRPr sz="2000" b="1" i="0">
+                <a:solidFill>
+                  <a:srgbClr val="1E293B"/>
+                </a:solidFill>
+              </a:defRPr>
+            </a:pPr>
+            <a:r>
+              <a:t>June 15th</a:t>
+            </a:r>
+          </a:p>
+        </p:txBody>
+      </p:sp>
+      <p:sp>
+        <p:nvSpPr>
+          <p:cNvPr id="22" name="Rounded Rectangle 21"/>
           <p:cNvSpPr/>
           <p:nvPr/>
         </p:nvSpPr>
         <p:spPr>
           <a:xfrm>
-            <a:off x="8960774" y="6583680"/>
-            <a:ext cx="2560666" cy="164592"/>
+            <a:off x="6690207" y="3200400"/>
+            <a:ext cx="1005840" cy="320040"/>
           </a:xfrm>
           <a:prstGeom prst="roundRect">
             <a:avLst>
-              <a:gd name="adj" fmla="val 15000"/>
+              <a:gd name="adj" fmla="val 30000"/>
             </a:avLst>
           </a:prstGeom>
           <a:solidFill>
@@ -4443,23 +3933,32 @@
           </a:fontRef>
         </p:style>
         <p:txBody>
-          <a:bodyPr rtlCol="0" anchor="ctr"/>
-          <a:lstStyle/>
-          <a:p>
-            <a:pPr algn="ctr"/>
-          </a:p>
-        </p:txBody>
-      </p:sp>
-      <p:sp>
-        <p:nvSpPr>
-          <p:cNvPr id="30" name="TextBox 29"/>
+          <a:bodyPr rtlCol="0" anchor="t"/>
+          <a:lstStyle/>
+          <a:p>
+            <a:pPr algn="ctr">
+              <a:defRPr sz="1200" b="1">
+                <a:solidFill>
+                  <a:srgbClr val="FFFFFF"/>
+                </a:solidFill>
+              </a:defRPr>
+            </a:pPr>
+            <a:r>
+              <a:t>+141.6%</a:t>
+            </a:r>
+          </a:p>
+        </p:txBody>
+      </p:sp>
+      <p:sp>
+        <p:nvSpPr>
+          <p:cNvPr id="23" name="TextBox 22"/>
           <p:cNvSpPr txBox="1"/>
           <p:nvPr/>
         </p:nvSpPr>
         <p:spPr>
           <a:xfrm>
-            <a:off x="731520" y="6355080"/>
-            <a:ext cx="1828800" cy="320040"/>
+            <a:off x="6690207" y="3657600"/>
+            <a:ext cx="4114800" cy="320040"/>
           </a:xfrm>
           <a:prstGeom prst="rect">
             <a:avLst/>
@@ -4473,14 +3972,733 @@
           <a:lstStyle/>
           <a:p>
             <a:pPr algn="l">
-              <a:defRPr sz="1600" b="1" i="1">
+              <a:defRPr sz="1600" b="1" i="0">
+                <a:solidFill>
+                  <a:srgbClr val="1E293B"/>
+                </a:solidFill>
+              </a:defRPr>
+            </a:pPr>
+            <a:r>
+              <a:t>Total Accounts: 2,650</a:t>
+            </a:r>
+          </a:p>
+        </p:txBody>
+      </p:sp>
+      <p:sp>
+        <p:nvSpPr>
+          <p:cNvPr id="24" name="TextBox 23"/>
+          <p:cNvSpPr txBox="1"/>
+          <p:nvPr/>
+        </p:nvSpPr>
+        <p:spPr>
+          <a:xfrm>
+            <a:off x="6690207" y="4160520"/>
+            <a:ext cx="4114800" cy="292608"/>
+          </a:xfrm>
+          <a:prstGeom prst="rect">
+            <a:avLst/>
+          </a:prstGeom>
+          <a:noFill/>
+        </p:spPr>
+        <p:txBody>
+          <a:bodyPr wrap="square">
+            <a:spAutoFit/>
+          </a:bodyPr>
+          <a:lstStyle/>
+          <a:p>
+            <a:pPr algn="l">
+              <a:defRPr sz="1400" b="1" i="0">
                 <a:solidFill>
                   <a:srgbClr val="1B4F8A"/>
                 </a:solidFill>
               </a:defRPr>
             </a:pPr>
             <a:r>
+              <a:t>LITE Segment: 840 (31.7%)</a:t>
+            </a:r>
+          </a:p>
+        </p:txBody>
+      </p:sp>
+      <p:sp>
+        <p:nvSpPr>
+          <p:cNvPr id="25" name="TextBox 24"/>
+          <p:cNvSpPr txBox="1"/>
+          <p:nvPr/>
+        </p:nvSpPr>
+        <p:spPr>
+          <a:xfrm>
+            <a:off x="6690207" y="4544568"/>
+            <a:ext cx="4114800" cy="292608"/>
+          </a:xfrm>
+          <a:prstGeom prst="rect">
+            <a:avLst/>
+          </a:prstGeom>
+          <a:noFill/>
+        </p:spPr>
+        <p:txBody>
+          <a:bodyPr wrap="square">
+            <a:spAutoFit/>
+          </a:bodyPr>
+          <a:lstStyle/>
+          <a:p>
+            <a:pPr algn="l">
+              <a:defRPr sz="1400" b="1" i="0">
+                <a:solidFill>
+                  <a:srgbClr val="2E9E5B"/>
+                </a:solidFill>
+              </a:defRPr>
+            </a:pPr>
+            <a:r>
+              <a:t>SMB Segment: 1,810 (68.3%)</a:t>
+            </a:r>
+          </a:p>
+        </p:txBody>
+      </p:sp>
+      <p:sp>
+        <p:nvSpPr>
+          <p:cNvPr id="26" name="TextBox 25"/>
+          <p:cNvSpPr txBox="1"/>
+          <p:nvPr/>
+        </p:nvSpPr>
+        <p:spPr>
+          <a:xfrm>
+            <a:off x="6690207" y="4928616"/>
+            <a:ext cx="4114800" cy="292608"/>
+          </a:xfrm>
+          <a:prstGeom prst="rect">
+            <a:avLst/>
+          </a:prstGeom>
+          <a:noFill/>
+        </p:spPr>
+        <p:txBody>
+          <a:bodyPr wrap="square">
+            <a:spAutoFit/>
+          </a:bodyPr>
+          <a:lstStyle/>
+          <a:p>
+            <a:pPr algn="l">
+              <a:defRPr sz="1400" b="0" i="1">
+                <a:solidFill>
+                  <a:srgbClr val="9CA3AF"/>
+                </a:solidFill>
+              </a:defRPr>
+            </a:pPr>
+            <a:r>
+              <a:t>Mid-Market: Pending</a:t>
+            </a:r>
+          </a:p>
+        </p:txBody>
+      </p:sp>
+      <p:sp>
+        <p:nvSpPr>
+          <p:cNvPr id="27" name="Rounded Rectangle 26"/>
+          <p:cNvSpPr/>
+          <p:nvPr/>
+        </p:nvSpPr>
+        <p:spPr>
+          <a:xfrm>
+            <a:off x="6690207" y="5431536"/>
+            <a:ext cx="1304313" cy="201168"/>
+          </a:xfrm>
+          <a:prstGeom prst="roundRect">
+            <a:avLst>
+              <a:gd name="adj" fmla="val 20000"/>
+            </a:avLst>
+          </a:prstGeom>
+          <a:solidFill>
+            <a:srgbClr val="1B4F8A"/>
+          </a:solidFill>
+          <a:ln>
+            <a:noFill/>
+          </a:ln>
+        </p:spPr>
+        <p:style>
+          <a:lnRef idx="1">
+            <a:schemeClr val="accent1"/>
+          </a:lnRef>
+          <a:fillRef idx="3">
+            <a:schemeClr val="accent1"/>
+          </a:fillRef>
+          <a:effectRef idx="2">
+            <a:schemeClr val="accent1"/>
+          </a:effectRef>
+          <a:fontRef idx="minor">
+            <a:schemeClr val="lt1"/>
+          </a:fontRef>
+        </p:style>
+        <p:txBody>
+          <a:bodyPr rtlCol="0" anchor="ctr"/>
+          <a:lstStyle/>
+          <a:p>
+            <a:pPr algn="ctr"/>
+          </a:p>
+        </p:txBody>
+      </p:sp>
+      <p:sp>
+        <p:nvSpPr>
+          <p:cNvPr id="28" name="Rounded Rectangle 27"/>
+          <p:cNvSpPr/>
+          <p:nvPr/>
+        </p:nvSpPr>
+        <p:spPr>
+          <a:xfrm>
+            <a:off x="7994520" y="5431536"/>
+            <a:ext cx="2810487" cy="201168"/>
+          </a:xfrm>
+          <a:prstGeom prst="roundRect">
+            <a:avLst>
+              <a:gd name="adj" fmla="val 20000"/>
+            </a:avLst>
+          </a:prstGeom>
+          <a:solidFill>
+            <a:srgbClr val="2E9E5B"/>
+          </a:solidFill>
+          <a:ln>
+            <a:noFill/>
+          </a:ln>
+        </p:spPr>
+        <p:style>
+          <a:lnRef idx="1">
+            <a:schemeClr val="accent1"/>
+          </a:lnRef>
+          <a:fillRef idx="3">
+            <a:schemeClr val="accent1"/>
+          </a:fillRef>
+          <a:effectRef idx="2">
+            <a:schemeClr val="accent1"/>
+          </a:effectRef>
+          <a:fontRef idx="minor">
+            <a:schemeClr val="lt1"/>
+          </a:fontRef>
+        </p:style>
+        <p:txBody>
+          <a:bodyPr rtlCol="0" anchor="ctr"/>
+          <a:lstStyle/>
+          <a:p>
+            <a:pPr algn="ctr"/>
+          </a:p>
+        </p:txBody>
+      </p:sp>
+      <p:sp>
+        <p:nvSpPr>
+          <p:cNvPr id="29" name="TextBox 28"/>
+          <p:cNvSpPr txBox="1"/>
+          <p:nvPr/>
+        </p:nvSpPr>
+        <p:spPr>
+          <a:xfrm>
+            <a:off x="731520" y="6263640"/>
+            <a:ext cx="1828800" cy="365760"/>
+          </a:xfrm>
+          <a:prstGeom prst="rect">
+            <a:avLst/>
+          </a:prstGeom>
+          <a:noFill/>
+        </p:spPr>
+        <p:txBody>
+          <a:bodyPr wrap="square">
+            <a:spAutoFit/>
+          </a:bodyPr>
+          <a:lstStyle/>
+          <a:p>
+            <a:pPr algn="l">
+              <a:defRPr sz="1800" b="1" i="1">
+                <a:solidFill>
+                  <a:srgbClr val="1B4F8A"/>
+                </a:solidFill>
+              </a:defRPr>
+            </a:pPr>
+            <a:r>
               <a:t>Guesty</a:t>
+            </a:r>
+          </a:p>
+        </p:txBody>
+      </p:sp>
+    </p:spTree>
+  </p:cSld>
+  <p:clrMapOvr>
+    <a:masterClrMapping/>
+  </p:clrMapOvr>
+</p:sld>
+</file>
+
+<file path=ppt/slides/slide2.xml><?xml version="1.0" encoding="utf-8"?>
+<p:sld xmlns:a="http://schemas.openxmlformats.org/drawingml/2006/main" xmlns:p="http://schemas.openxmlformats.org/presentationml/2006/main" xmlns:r="http://schemas.openxmlformats.org/officeDocument/2006/relationships">
+  <p:cSld>
+    <p:spTree>
+      <p:nvGrpSpPr>
+        <p:cNvPr id="1" name=""/>
+        <p:cNvGrpSpPr/>
+        <p:nvPr/>
+      </p:nvGrpSpPr>
+      <p:grpSpPr/>
+      <p:sp>
+        <p:nvSpPr>
+          <p:cNvPr id="2" name="Rectangle 1"/>
+          <p:cNvSpPr/>
+          <p:nvPr/>
+        </p:nvSpPr>
+        <p:spPr>
+          <a:xfrm>
+            <a:off x="0" y="0"/>
+            <a:ext cx="12191695" cy="6858000"/>
+          </a:xfrm>
+          <a:prstGeom prst="rect">
+            <a:avLst/>
+          </a:prstGeom>
+          <a:solidFill>
+            <a:srgbClr val="F5F0E8"/>
+          </a:solidFill>
+          <a:ln>
+            <a:noFill/>
+          </a:ln>
+        </p:spPr>
+        <p:style>
+          <a:lnRef idx="1">
+            <a:schemeClr val="accent1"/>
+          </a:lnRef>
+          <a:fillRef idx="3">
+            <a:schemeClr val="accent1"/>
+          </a:fillRef>
+          <a:effectRef idx="2">
+            <a:schemeClr val="accent1"/>
+          </a:effectRef>
+          <a:fontRef idx="minor">
+            <a:schemeClr val="lt1"/>
+          </a:fontRef>
+        </p:style>
+        <p:txBody>
+          <a:bodyPr rtlCol="0" anchor="ctr"/>
+          <a:lstStyle/>
+          <a:p>
+            <a:pPr algn="ctr"/>
+          </a:p>
+        </p:txBody>
+      </p:sp>
+      <p:sp>
+        <p:nvSpPr>
+          <p:cNvPr id="3" name="TextBox 2"/>
+          <p:cNvSpPr txBox="1"/>
+          <p:nvPr/>
+        </p:nvSpPr>
+        <p:spPr>
+          <a:xfrm>
+            <a:off x="731520" y="457200"/>
+            <a:ext cx="9144000" cy="548640"/>
+          </a:xfrm>
+          <a:prstGeom prst="rect">
+            <a:avLst/>
+          </a:prstGeom>
+          <a:noFill/>
+        </p:spPr>
+        <p:txBody>
+          <a:bodyPr wrap="square">
+            <a:spAutoFit/>
+          </a:bodyPr>
+          <a:lstStyle/>
+          <a:p>
+            <a:pPr algn="l">
+              <a:defRPr sz="2400" b="1" i="0">
+                <a:solidFill>
+                  <a:srgbClr val="1E293B"/>
+                </a:solidFill>
+              </a:defRPr>
+            </a:pPr>
+            <a:r>
+              <a:t>Migration Data (Editable)</a:t>
+            </a:r>
+          </a:p>
+        </p:txBody>
+      </p:sp>
+      <p:graphicFrame>
+        <p:nvGraphicFramePr>
+          <p:cNvPr id="4" name="Table 3"/>
+          <p:cNvGraphicFramePr>
+            <a:graphicFrameLocks noGrp="1"/>
+          </p:cNvGraphicFramePr>
+          <p:nvPr/>
+        </p:nvGraphicFramePr>
+        <p:xfrm>
+          <a:off x="731520" y="1371600"/>
+          <a:ext cx="10515600" cy="1645920"/>
+        </p:xfrm>
+        <a:graphic>
+          <a:graphicData uri="http://schemas.openxmlformats.org/drawingml/2006/table">
+            <a:tbl>
+              <a:tblPr firstRow="1" bandRow="1">
+                <a:tableStyleId>{5C22544A-7EE6-4342-B048-85BDC9FD1C3A}</a:tableStyleId>
+              </a:tblPr>
+              <a:tblGrid>
+                <a:gridCol w="1752600"/>
+                <a:gridCol w="1752600"/>
+                <a:gridCol w="1752600"/>
+                <a:gridCol w="1752600"/>
+                <a:gridCol w="1752600"/>
+                <a:gridCol w="1752600"/>
+              </a:tblGrid>
+              <a:tr h="548640">
+                <a:tc>
+                  <a:txBody>
+                    <a:bodyPr/>
+                    <a:lstStyle/>
+                    <a:p>
+                      <a:pPr>
+                        <a:defRPr b="1" sz="1200">
+                          <a:solidFill>
+                            <a:srgbClr val="FFFFFF"/>
+                          </a:solidFill>
+                        </a:defRPr>
+                      </a:pPr>
+                      <a:r>
+                        <a:t>Date</a:t>
+                      </a:r>
+                    </a:p>
+                  </a:txBody>
+                  <a:tcPr>
+                    <a:solidFill>
+                      <a:srgbClr val="1B4F8A"/>
+                    </a:solidFill>
+                  </a:tcPr>
+                </a:tc>
+                <a:tc>
+                  <a:txBody>
+                    <a:bodyPr/>
+                    <a:lstStyle/>
+                    <a:p>
+                      <a:pPr>
+                        <a:defRPr b="1" sz="1200">
+                          <a:solidFill>
+                            <a:srgbClr val="FFFFFF"/>
+                          </a:solidFill>
+                        </a:defRPr>
+                      </a:pPr>
+                      <a:r>
+                        <a:t>Total Accounts</a:t>
+                      </a:r>
+                    </a:p>
+                  </a:txBody>
+                  <a:tcPr>
+                    <a:solidFill>
+                      <a:srgbClr val="1B4F8A"/>
+                    </a:solidFill>
+                  </a:tcPr>
+                </a:tc>
+                <a:tc>
+                  <a:txBody>
+                    <a:bodyPr/>
+                    <a:lstStyle/>
+                    <a:p>
+                      <a:pPr>
+                        <a:defRPr b="1" sz="1200">
+                          <a:solidFill>
+                            <a:srgbClr val="FFFFFF"/>
+                          </a:solidFill>
+                        </a:defRPr>
+                      </a:pPr>
+                      <a:r>
+                        <a:t>LITE</a:t>
+                      </a:r>
+                    </a:p>
+                  </a:txBody>
+                  <a:tcPr>
+                    <a:solidFill>
+                      <a:srgbClr val="1B4F8A"/>
+                    </a:solidFill>
+                  </a:tcPr>
+                </a:tc>
+                <a:tc>
+                  <a:txBody>
+                    <a:bodyPr/>
+                    <a:lstStyle/>
+                    <a:p>
+                      <a:pPr>
+                        <a:defRPr b="1" sz="1200">
+                          <a:solidFill>
+                            <a:srgbClr val="FFFFFF"/>
+                          </a:solidFill>
+                        </a:defRPr>
+                      </a:pPr>
+                      <a:r>
+                        <a:t>SMB</a:t>
+                      </a:r>
+                    </a:p>
+                  </a:txBody>
+                  <a:tcPr>
+                    <a:solidFill>
+                      <a:srgbClr val="1B4F8A"/>
+                    </a:solidFill>
+                  </a:tcPr>
+                </a:tc>
+                <a:tc>
+                  <a:txBody>
+                    <a:bodyPr/>
+                    <a:lstStyle/>
+                    <a:p>
+                      <a:pPr>
+                        <a:defRPr b="1" sz="1200">
+                          <a:solidFill>
+                            <a:srgbClr val="FFFFFF"/>
+                          </a:solidFill>
+                        </a:defRPr>
+                      </a:pPr>
+                      <a:r>
+                        <a:t>Mid-Market</a:t>
+                      </a:r>
+                    </a:p>
+                  </a:txBody>
+                  <a:tcPr>
+                    <a:solidFill>
+                      <a:srgbClr val="1B4F8A"/>
+                    </a:solidFill>
+                  </a:tcPr>
+                </a:tc>
+                <a:tc>
+                  <a:txBody>
+                    <a:bodyPr/>
+                    <a:lstStyle/>
+                    <a:p>
+                      <a:pPr>
+                        <a:defRPr b="1" sz="1200">
+                          <a:solidFill>
+                            <a:srgbClr val="FFFFFF"/>
+                          </a:solidFill>
+                        </a:defRPr>
+                      </a:pPr>
+                      <a:r>
+                        <a:t>Change %</a:t>
+                      </a:r>
+                    </a:p>
+                  </a:txBody>
+                  <a:tcPr>
+                    <a:solidFill>
+                      <a:srgbClr val="1B4F8A"/>
+                    </a:solidFill>
+                  </a:tcPr>
+                </a:tc>
+              </a:tr>
+              <a:tr h="548640">
+                <a:tc>
+                  <a:txBody>
+                    <a:bodyPr/>
+                    <a:lstStyle/>
+                    <a:p>
+                      <a:pPr>
+                        <a:defRPr sz="1100"/>
+                      </a:pPr>
+                      <a:r>
+                        <a:t>June 8th</a:t>
+                      </a:r>
+                    </a:p>
+                  </a:txBody>
+                  <a:tcPr/>
+                </a:tc>
+                <a:tc>
+                  <a:txBody>
+                    <a:bodyPr/>
+                    <a:lstStyle/>
+                    <a:p>
+                      <a:pPr>
+                        <a:defRPr sz="1100"/>
+                      </a:pPr>
+                      <a:r>
+                        <a:t>1,097</a:t>
+                      </a:r>
+                    </a:p>
+                  </a:txBody>
+                  <a:tcPr/>
+                </a:tc>
+                <a:tc>
+                  <a:txBody>
+                    <a:bodyPr/>
+                    <a:lstStyle/>
+                    <a:p>
+                      <a:pPr>
+                        <a:defRPr sz="1100"/>
+                      </a:pPr>
+                      <a:r>
+                        <a:t>380 (34.6%)</a:t>
+                      </a:r>
+                    </a:p>
+                  </a:txBody>
+                  <a:tcPr/>
+                </a:tc>
+                <a:tc>
+                  <a:txBody>
+                    <a:bodyPr/>
+                    <a:lstStyle/>
+                    <a:p>
+                      <a:pPr>
+                        <a:defRPr sz="1100"/>
+                      </a:pPr>
+                      <a:r>
+                        <a:t>717 (65.4%)</a:t>
+                      </a:r>
+                    </a:p>
+                  </a:txBody>
+                  <a:tcPr/>
+                </a:tc>
+                <a:tc>
+                  <a:txBody>
+                    <a:bodyPr/>
+                    <a:lstStyle/>
+                    <a:p>
+                      <a:pPr>
+                        <a:defRPr sz="1100"/>
+                      </a:pPr>
+                      <a:r>
+                        <a:t>0 (0.0%)</a:t>
+                      </a:r>
+                    </a:p>
+                  </a:txBody>
+                  <a:tcPr/>
+                </a:tc>
+                <a:tc>
+                  <a:txBody>
+                    <a:bodyPr/>
+                    <a:lstStyle/>
+                    <a:p>
+                      <a:pPr>
+                        <a:defRPr sz="1100"/>
+                      </a:pPr>
+                      <a:r>
+                        <a:t>—</a:t>
+                      </a:r>
+                    </a:p>
+                  </a:txBody>
+                  <a:tcPr/>
+                </a:tc>
+              </a:tr>
+              <a:tr h="548640">
+                <a:tc>
+                  <a:txBody>
+                    <a:bodyPr/>
+                    <a:lstStyle/>
+                    <a:p>
+                      <a:pPr>
+                        <a:defRPr sz="1100"/>
+                      </a:pPr>
+                      <a:r>
+                        <a:t>June 15th</a:t>
+                      </a:r>
+                    </a:p>
+                  </a:txBody>
+                  <a:tcPr/>
+                </a:tc>
+                <a:tc>
+                  <a:txBody>
+                    <a:bodyPr/>
+                    <a:lstStyle/>
+                    <a:p>
+                      <a:pPr>
+                        <a:defRPr sz="1100"/>
+                      </a:pPr>
+                      <a:r>
+                        <a:t>2,650</a:t>
+                      </a:r>
+                    </a:p>
+                  </a:txBody>
+                  <a:tcPr/>
+                </a:tc>
+                <a:tc>
+                  <a:txBody>
+                    <a:bodyPr/>
+                    <a:lstStyle/>
+                    <a:p>
+                      <a:pPr>
+                        <a:defRPr sz="1100"/>
+                      </a:pPr>
+                      <a:r>
+                        <a:t>840 (31.7%)</a:t>
+                      </a:r>
+                    </a:p>
+                  </a:txBody>
+                  <a:tcPr/>
+                </a:tc>
+                <a:tc>
+                  <a:txBody>
+                    <a:bodyPr/>
+                    <a:lstStyle/>
+                    <a:p>
+                      <a:pPr>
+                        <a:defRPr sz="1100"/>
+                      </a:pPr>
+                      <a:r>
+                        <a:t>1,810 (68.3%)</a:t>
+                      </a:r>
+                    </a:p>
+                  </a:txBody>
+                  <a:tcPr/>
+                </a:tc>
+                <a:tc>
+                  <a:txBody>
+                    <a:bodyPr/>
+                    <a:lstStyle/>
+                    <a:p>
+                      <a:pPr>
+                        <a:defRPr sz="1100"/>
+                      </a:pPr>
+                      <a:r>
+                        <a:t>Pending</a:t>
+                      </a:r>
+                    </a:p>
+                  </a:txBody>
+                  <a:tcPr/>
+                </a:tc>
+                <a:tc>
+                  <a:txBody>
+                    <a:bodyPr/>
+                    <a:lstStyle/>
+                    <a:p>
+                      <a:pPr>
+                        <a:defRPr sz="1100"/>
+                      </a:pPr>
+                      <a:r>
+                        <a:t>+141.6%</a:t>
+                      </a:r>
+                    </a:p>
+                  </a:txBody>
+                  <a:tcPr/>
+                </a:tc>
+              </a:tr>
+            </a:tbl>
+          </a:graphicData>
+        </a:graphic>
+      </p:graphicFrame>
+      <p:sp>
+        <p:nvSpPr>
+          <p:cNvPr id="5" name="TextBox 4"/>
+          <p:cNvSpPr txBox="1"/>
+          <p:nvPr/>
+        </p:nvSpPr>
+        <p:spPr>
+          <a:xfrm>
+            <a:off x="731520" y="3291840"/>
+            <a:ext cx="10058400" cy="1828800"/>
+          </a:xfrm>
+          <a:prstGeom prst="rect">
+            <a:avLst/>
+          </a:prstGeom>
+          <a:noFill/>
+        </p:spPr>
+        <p:txBody>
+          <a:bodyPr wrap="square">
+            <a:spAutoFit/>
+          </a:bodyPr>
+          <a:lstStyle/>
+          <a:p>
+            <a:pPr algn="l">
+              <a:defRPr sz="1200" b="0" i="1">
+                <a:solidFill>
+                  <a:srgbClr val="9CA3AF"/>
+                </a:solidFill>
+              </a:defRPr>
+            </a:pPr>
+            <a:r>
+              <a:t>Edit the table above, then update the visual slide to match.</a:t>
+            </a:r>
+            <a:br/>
+            <a:r>
+              <a:t>Tip: In Google Slides, click any text box or table cell to edit directly.</a:t>
             </a:r>
           </a:p>
         </p:txBody>

</xml_diff>